<commit_message>
Deploy hub update for Titans Coaching
</commit_message>
<xml_diff>
--- a/webinar/titans-coaching-webinar-deck.pptx
+++ b/webinar/titans-coaching-webinar-deck.pptx
@@ -3175,16 +3175,40 @@
           </a:p>
         </p:txBody>
       </p:sp>
-      <p:sp>
-        <p:nvSpPr>
-          <p:cNvPr id="3" name="TextBox 2"/>
+      <p:pic>
+        <p:nvPicPr>
+          <p:cNvPr id="3" name="Picture 2" descr="crest-gold-fade.jpg"/>
+          <p:cNvPicPr>
+            <a:picLocks noChangeAspect="1"/>
+          </p:cNvPicPr>
+          <p:nvPr/>
+        </p:nvPicPr>
+        <p:blipFill>
+          <a:blip r:embed="rId2"/>
+          <a:stretch>
+            <a:fillRect/>
+          </a:stretch>
+        </p:blipFill>
+        <p:spPr>
+          <a:xfrm>
+            <a:off x="4723599" y="274320"/>
+            <a:ext cx="2744497" cy="2103120"/>
+          </a:xfrm>
+          <a:prstGeom prst="rect">
+            <a:avLst/>
+          </a:prstGeom>
+        </p:spPr>
+      </p:pic>
+      <p:sp>
+        <p:nvSpPr>
+          <p:cNvPr id="4" name="TextBox 3"/>
           <p:cNvSpPr txBox="1"/>
           <p:nvPr/>
         </p:nvSpPr>
         <p:spPr>
           <a:xfrm>
-            <a:off x="914400" y="1737360"/>
-            <a:ext cx="10332720" cy="2926080"/>
+            <a:off x="914400" y="2514600"/>
+            <a:ext cx="10332720" cy="2377440"/>
           </a:xfrm>
           <a:prstGeom prst="rect">
             <a:avLst/>
@@ -3203,7 +3227,7 @@
               </a:spcAft>
             </a:pPr>
             <a:r>
-              <a:rPr sz="6000" b="1" i="0">
+              <a:rPr sz="5400" b="1" i="0">
                 <a:solidFill>
                   <a:srgbClr val="FFFFFF"/>
                 </a:solidFill>
@@ -3215,11 +3239,11 @@
           <a:p>
             <a:pPr algn="ctr">
               <a:spcAft>
-                <a:spcPts val="1600"/>
-              </a:spcAft>
-            </a:pPr>
-            <a:r>
-              <a:rPr sz="6000" b="1" i="0">
+                <a:spcPts val="1400"/>
+              </a:spcAft>
+            </a:pPr>
+            <a:r>
+              <a:rPr sz="5400" b="1" i="0">
                 <a:solidFill>
                   <a:srgbClr val="3BCAE1"/>
                 </a:solidFill>
@@ -3235,7 +3259,7 @@
               </a:spcAft>
             </a:pPr>
             <a:r>
-              <a:rPr sz="2000" b="0" i="0">
+              <a:rPr sz="1900" b="0" i="0">
                 <a:solidFill>
                   <a:srgbClr val="8FA3B8"/>
                 </a:solidFill>
@@ -3248,13 +3272,13 @@
       </p:sp>
       <p:sp>
         <p:nvSpPr>
-          <p:cNvPr id="4" name="Rounded Rectangle 3"/>
+          <p:cNvPr id="5" name="Rounded Rectangle 4"/>
           <p:cNvSpPr/>
           <p:nvPr/>
         </p:nvSpPr>
         <p:spPr>
           <a:xfrm>
-            <a:off x="4041648" y="5120640"/>
+            <a:off x="4041648" y="5257800"/>
             <a:ext cx="4114800" cy="502920"/>
           </a:xfrm>
           <a:prstGeom prst="roundRect">
@@ -3303,7 +3327,7 @@
       </p:sp>
       <p:sp>
         <p:nvSpPr>
-          <p:cNvPr id="5" name="Rounded Rectangle 4"/>
+          <p:cNvPr id="6" name="Rounded Rectangle 5"/>
           <p:cNvSpPr/>
           <p:nvPr/>
         </p:nvSpPr>
@@ -5734,7 +5758,7 @@
         <p:spPr>
           <a:xfrm>
             <a:off x="685800" y="1371600"/>
-            <a:ext cx="10789920" cy="3108960"/>
+            <a:ext cx="7406640" cy="3108960"/>
           </a:xfrm>
           <a:prstGeom prst="rect">
             <a:avLst/>
@@ -5779,8 +5803,8 @@
         </p:nvSpPr>
         <p:spPr>
           <a:xfrm>
-            <a:off x="1097280" y="1645920"/>
-            <a:ext cx="9966960" cy="2560320"/>
+            <a:off x="1051560" y="1600200"/>
+            <a:ext cx="6720840" cy="2651760"/>
           </a:xfrm>
           <a:prstGeom prst="rect">
             <a:avLst/>
@@ -5799,7 +5823,7 @@
               </a:spcAft>
             </a:pPr>
             <a:r>
-              <a:rPr sz="2200" b="0" i="1">
+              <a:rPr sz="2000" b="0" i="1">
                 <a:solidFill>
                   <a:srgbClr val="FFFFFF"/>
                 </a:solidFill>
@@ -5815,7 +5839,7 @@
               </a:spcAft>
             </a:pPr>
             <a:r>
-              <a:rPr sz="1500" b="1" i="0">
+              <a:rPr sz="1400" b="1" i="0">
                 <a:solidFill>
                   <a:srgbClr val="C8AA6E"/>
                 </a:solidFill>
@@ -5831,20 +5855,49 @@
               </a:spcAft>
             </a:pPr>
             <a:r>
-              <a:rPr sz="1200" b="0" i="0">
+              <a:rPr sz="1100" b="0" i="0">
                 <a:solidFill>
                   <a:srgbClr val="8FA3B8"/>
                 </a:solidFill>
                 <a:latin typeface="Arial"/>
               </a:rPr>
-              <a:t>fuente: pagina del Acelerador de titanscoaching.cl</a:t>
-            </a:r>
-          </a:p>
-        </p:txBody>
-      </p:sp>
-      <p:sp>
-        <p:nvSpPr>
-          <p:cNvPr id="5" name="TextBox 4"/>
+              <a:t>cita: pagina del Acelerador · captura: VSL de titanscoaching.cl</a:t>
+            </a:r>
+          </a:p>
+        </p:txBody>
+      </p:sp>
+      <p:pic>
+        <p:nvPicPr>
+          <p:cNvPr id="5" name="Picture 4" descr="testimonio-vaporeon-retador.jpg"/>
+          <p:cNvPicPr>
+            <a:picLocks noChangeAspect="1"/>
+          </p:cNvPicPr>
+          <p:nvPr/>
+        </p:nvPicPr>
+        <p:blipFill>
+          <a:blip r:embed="rId2"/>
+          <a:stretch>
+            <a:fillRect/>
+          </a:stretch>
+        </p:blipFill>
+        <p:spPr>
+          <a:xfrm>
+            <a:off x="8366760" y="1371600"/>
+            <a:ext cx="2487168" cy="3108960"/>
+          </a:xfrm>
+          <a:prstGeom prst="rect">
+            <a:avLst/>
+          </a:prstGeom>
+          <a:ln w="19050">
+            <a:solidFill>
+              <a:srgbClr val="C8AA6E"/>
+            </a:solidFill>
+          </a:ln>
+        </p:spPr>
+      </p:pic>
+      <p:sp>
+        <p:nvSpPr>
+          <p:cNvPr id="6" name="TextBox 5"/>
           <p:cNvSpPr txBox="1"/>
           <p:nvPr/>
         </p:nvSpPr>
@@ -7053,7 +7106,7 @@
         <p:spPr>
           <a:xfrm>
             <a:off x="502920" y="822960"/>
-            <a:ext cx="11185855" cy="2011680"/>
+            <a:ext cx="7498079" cy="2011680"/>
           </a:xfrm>
           <a:prstGeom prst="rect">
             <a:avLst/>
@@ -7072,7 +7125,7 @@
               </a:spcAft>
             </a:pPr>
             <a:r>
-              <a:rPr sz="3400" b="1" i="0">
+              <a:rPr sz="3200" b="1" i="0">
                 <a:solidFill>
                   <a:srgbClr val="FFFFFF"/>
                 </a:solidFill>
@@ -7092,7 +7145,7 @@
         <p:spPr>
           <a:xfrm>
             <a:off x="685800" y="2468880"/>
-            <a:ext cx="10820095" cy="3566160"/>
+            <a:ext cx="6949440" cy="3566160"/>
           </a:xfrm>
           <a:prstGeom prst="rect">
             <a:avLst/>
@@ -7111,7 +7164,7 @@
               </a:spcAft>
             </a:pPr>
             <a:r>
-              <a:rPr sz="2100" b="0" i="0">
+              <a:rPr sz="2000" b="0" i="0">
                 <a:solidFill>
                   <a:srgbClr val="FFFFFF"/>
                 </a:solidFill>
@@ -7127,7 +7180,7 @@
               </a:spcAft>
             </a:pPr>
             <a:r>
-              <a:rPr sz="2100" b="0" i="0">
+              <a:rPr sz="2000" b="0" i="0">
                 <a:solidFill>
                   <a:srgbClr val="FFFFFF"/>
                 </a:solidFill>
@@ -7143,7 +7196,7 @@
               </a:spcAft>
             </a:pPr>
             <a:r>
-              <a:rPr sz="2100" b="0" i="0">
+              <a:rPr sz="2000" b="0" i="0">
                 <a:solidFill>
                   <a:srgbClr val="FFFFFF"/>
                 </a:solidFill>
@@ -7162,8 +7215,8 @@
         </p:nvSpPr>
         <p:spPr>
           <a:xfrm>
-            <a:off x="685800" y="5029200"/>
-            <a:ext cx="10789920" cy="731520"/>
+            <a:off x="685800" y="5394960"/>
+            <a:ext cx="6949440" cy="731520"/>
           </a:xfrm>
           <a:prstGeom prst="rect">
             <a:avLst/>
@@ -7188,11 +7241,40 @@
                 </a:solidFill>
                 <a:latin typeface="Arial"/>
               </a:rPr>
-              <a:t>fuente: pagina del Acelerador de titanscoaching.cl</a:t>
-            </a:r>
-          </a:p>
-        </p:txBody>
-      </p:sp>
+              <a:t>cita: pagina del Acelerador · captura: VSL de titanscoaching.cl</a:t>
+            </a:r>
+          </a:p>
+        </p:txBody>
+      </p:sp>
+      <p:pic>
+        <p:nvPicPr>
+          <p:cNvPr id="6" name="Picture 5" descr="testimonio-light-challenger.jpg"/>
+          <p:cNvPicPr>
+            <a:picLocks noChangeAspect="1"/>
+          </p:cNvPicPr>
+          <p:nvPr/>
+        </p:nvPicPr>
+        <p:blipFill>
+          <a:blip r:embed="rId2"/>
+          <a:stretch>
+            <a:fillRect/>
+          </a:stretch>
+        </p:blipFill>
+        <p:spPr>
+          <a:xfrm>
+            <a:off x="8001000" y="1143000"/>
+            <a:ext cx="3584448" cy="4480560"/>
+          </a:xfrm>
+          <a:prstGeom prst="rect">
+            <a:avLst/>
+          </a:prstGeom>
+          <a:ln w="19050">
+            <a:solidFill>
+              <a:srgbClr val="C8AA6E"/>
+            </a:solidFill>
+          </a:ln>
+        </p:spPr>
+      </p:pic>
     </p:spTree>
   </p:cSld>
   <p:clrMapOvr>
@@ -11668,9 +11750,33 @@
           </a:p>
         </p:txBody>
       </p:sp>
-      <p:sp>
-        <p:nvSpPr>
-          <p:cNvPr id="3" name="TextBox 2"/>
+      <p:pic>
+        <p:nvPicPr>
+          <p:cNvPr id="3" name="Picture 2" descr="titans-logo.png"/>
+          <p:cNvPicPr>
+            <a:picLocks noChangeAspect="1"/>
+          </p:cNvPicPr>
+          <p:nvPr/>
+        </p:nvPicPr>
+        <p:blipFill>
+          <a:blip r:embed="rId2"/>
+          <a:stretch>
+            <a:fillRect/>
+          </a:stretch>
+        </p:blipFill>
+        <p:spPr>
+          <a:xfrm>
+            <a:off x="5467314" y="502920"/>
+            <a:ext cx="1257067" cy="1234440"/>
+          </a:xfrm>
+          <a:prstGeom prst="rect">
+            <a:avLst/>
+          </a:prstGeom>
+        </p:spPr>
+      </p:pic>
+      <p:sp>
+        <p:nvSpPr>
+          <p:cNvPr id="4" name="TextBox 3"/>
           <p:cNvSpPr txBox="1"/>
           <p:nvPr/>
         </p:nvSpPr>
@@ -11757,7 +11863,7 @@
       </p:sp>
       <p:sp>
         <p:nvSpPr>
-          <p:cNvPr id="4" name="Rectangle 3"/>
+          <p:cNvPr id="5" name="Rectangle 4"/>
           <p:cNvSpPr/>
           <p:nvPr/>
         </p:nvSpPr>
@@ -12483,62 +12589,35 @@
           </a:p>
         </p:txBody>
       </p:sp>
-      <p:sp>
-        <p:nvSpPr>
-          <p:cNvPr id="3" name="Rectangle 2"/>
-          <p:cNvSpPr/>
-          <p:nvPr/>
-        </p:nvSpPr>
-        <p:spPr>
-          <a:xfrm>
-            <a:off x="685800" y="1234440"/>
-            <a:ext cx="5852160" cy="4206240"/>
-          </a:xfrm>
-          <a:prstGeom prst="rect">
-            <a:avLst/>
-          </a:prstGeom>
-          <a:solidFill>
-            <a:srgbClr val="0D1826"/>
-          </a:solidFill>
+      <p:pic>
+        <p:nvPicPr>
+          <p:cNvPr id="3" name="Picture 2" descr="testimonio-sorien-retador.png"/>
+          <p:cNvPicPr>
+            <a:picLocks noChangeAspect="1"/>
+          </p:cNvPicPr>
+          <p:nvPr/>
+        </p:nvPicPr>
+        <p:blipFill>
+          <a:blip r:embed="rId2"/>
+          <a:stretch>
+            <a:fillRect/>
+          </a:stretch>
+        </p:blipFill>
+        <p:spPr>
+          <a:xfrm>
+            <a:off x="1828800" y="1051560"/>
+            <a:ext cx="3591426" cy="5029200"/>
+          </a:xfrm>
+          <a:prstGeom prst="rect">
+            <a:avLst/>
+          </a:prstGeom>
           <a:ln w="19050">
             <a:solidFill>
               <a:srgbClr val="C8AA6E"/>
             </a:solidFill>
-            <a:prstDash val="sysDash"/>
           </a:ln>
-          <a:effectLst/>
-        </p:spPr>
-        <p:style>
-          <a:lnRef idx="1">
-            <a:schemeClr val="accent1"/>
-          </a:lnRef>
-          <a:fillRef idx="3">
-            <a:schemeClr val="accent1"/>
-          </a:fillRef>
-          <a:effectRef idx="2">
-            <a:schemeClr val="accent1"/>
-          </a:effectRef>
-          <a:fontRef idx="minor">
-            <a:schemeClr val="lt1"/>
-          </a:fontRef>
-        </p:style>
-        <p:txBody>
-          <a:bodyPr rtlCol="0" anchor="ctr" wrap="square"/>
-          <a:lstStyle/>
-          <a:p>
-            <a:pPr algn="ctr"/>
-            <a:r>
-              <a:rPr sz="1300" b="1">
-                <a:solidFill>
-                  <a:srgbClr val="C8AA6E"/>
-                </a:solidFill>
-                <a:latin typeface="Arial"/>
-              </a:rPr>
-              <a:t>CAPTURA: screenshot real de Sorien (VSL de Titans)</a:t>
-            </a:r>
-          </a:p>
-        </p:txBody>
-      </p:sp>
+        </p:spPr>
+      </p:pic>
       <p:sp>
         <p:nvSpPr>
           <p:cNvPr id="4" name="TextBox 3"/>

</xml_diff>